<commit_message>
grid systems and media query tasks
</commit_message>
<xml_diff>
--- a/august/day 17/task/Day1.pptx
+++ b/august/day 17/task/Day1.pptx
@@ -6789,6 +6789,9 @@
             <a:off x="1097280" y="2048976"/>
             <a:ext cx="10058400" cy="435688"/>
           </a:xfrm>
+          <a:solidFill>
+            <a:srgbClr val="F1F1F1"/>
+          </a:solidFill>
         </p:spPr>
       </p:pic>
       <p:pic>
@@ -8180,13 +8183,19 @@
 </file>
 
 <file path=customXml/itemProps1.xml><?xml version="1.0" encoding="utf-8"?>
-<ds:datastoreItem xmlns:ds="http://schemas.openxmlformats.org/officeDocument/2006/customXml" ds:itemID="{DEB5386E-31AB-45E3-8C1B-1E31DD20FA08}"/>
+<ds:datastoreItem xmlns:ds="http://schemas.openxmlformats.org/officeDocument/2006/customXml" ds:itemID="{DEB5386E-31AB-45E3-8C1B-1E31DD20FA08}">
+  <ds:schemaRefs/>
+</ds:datastoreItem>
 </file>
 
 <file path=customXml/itemProps2.xml><?xml version="1.0" encoding="utf-8"?>
-<ds:datastoreItem xmlns:ds="http://schemas.openxmlformats.org/officeDocument/2006/customXml" ds:itemID="{1BF120A6-5188-45E8-B686-395629D7BEDA}"/>
+<ds:datastoreItem xmlns:ds="http://schemas.openxmlformats.org/officeDocument/2006/customXml" ds:itemID="{1BF120A6-5188-45E8-B686-395629D7BEDA}">
+  <ds:schemaRefs/>
+</ds:datastoreItem>
 </file>
 
 <file path=customXml/itemProps3.xml><?xml version="1.0" encoding="utf-8"?>
-<ds:datastoreItem xmlns:ds="http://schemas.openxmlformats.org/officeDocument/2006/customXml" ds:itemID="{BB320A0C-06E4-44FB-8E83-A02634B5AB06}"/>
+<ds:datastoreItem xmlns:ds="http://schemas.openxmlformats.org/officeDocument/2006/customXml" ds:itemID="{BB320A0C-06E4-44FB-8E83-A02634B5AB06}">
+  <ds:schemaRefs/>
+</ds:datastoreItem>
 </file>
</xml_diff>